<commit_message>
Soften wording on SME 言い訳外し / peer slides
押しの強い表現をマイルドに:
- スライド4: 「御社が思うやらない理由は、もう越えています」→
  「最初は皆さま同じご不安。同じような会社も無理なく始めています」に。
  断定語(むしろ/先頭集団/もう越えて)を排し、共感＋事実ベースの言い回しへ
- スライド2: ピアのパネルを「特別な準備がなくても始められます」に緩和

Co-Authored-By: Claude Opus 4.8 <noreply@anthropic.com>
Claude-Session: https://claude.ai/code/session_01NhMukK23UTNtqbV2vynVXs
</commit_message>
<xml_diff>
--- a/proposal/ai-training-proposal-sme.pptx
+++ b/proposal/ai-training-proposal-sme.pptx
@@ -16143,7 +16143,7 @@
                 <a:ea typeface="游ゴシック"/>
                 <a:cs typeface="游ゴシック"/>
               </a:rPr>
-              <a:t>むしろ </a:t>
+              <a:t>実際には、</a:t>
             </a:r>
             <a:r>
               <a:rPr sz="1450" b="1" i="0">
@@ -16154,7 +16154,7 @@
                 <a:ea typeface="游ゴシック"/>
                 <a:cs typeface="游ゴシック"/>
               </a:rPr>
-              <a:t>50名いかない会社・事務3〜5名の会社</a:t>
+              <a:t>数名〜数十名規模の会社</a:t>
             </a:r>
             <a:r>
               <a:rPr sz="1450" b="0" i="0">
@@ -16165,18 +16165,7 @@
                 <a:ea typeface="游ゴシック"/>
                 <a:cs typeface="游ゴシック"/>
               </a:rPr>
-              <a:t>が一番多く始めています。</a:t>
-            </a:r>
-            <a:r>
-              <a:rPr sz="1450" b="0" i="0">
-                <a:solidFill>
-                  <a:srgbClr val="1B2230"/>
-                </a:solidFill>
-                <a:latin typeface="Yu Gothic"/>
-                <a:ea typeface="游ゴシック"/>
-                <a:cs typeface="游ゴシック"/>
-              </a:rPr>
-              <a:t>  「うちはまだ早い」ということは、もうありません。</a:t>
+              <a:t>から始めるケースも多く、特別な準備がなくても始められます。</a:t>
             </a:r>
           </a:p>
         </p:txBody>
@@ -22171,7 +22160,7 @@
                 <a:ea typeface="游ゴシック"/>
                 <a:cs typeface="游ゴシック"/>
               </a:rPr>
-              <a:t>よくある“やらない理由”</a:t>
+              <a:t>最初によくいただくお声</a:t>
             </a:r>
           </a:p>
         </p:txBody>
@@ -22216,7 +22205,7 @@
                 <a:ea typeface="游ゴシック"/>
                 <a:cs typeface="游ゴシック"/>
               </a:rPr>
-              <a:t>御社が思う「やらない理由」は、</a:t>
+              <a:t>最初は、皆さま同じご不安からスタートします。</a:t>
             </a:r>
           </a:p>
           <a:p>
@@ -22240,7 +22229,7 @@
                 <a:ea typeface="游ゴシック"/>
                 <a:cs typeface="游ゴシック"/>
               </a:rPr>
-              <a:t>同じような会社が、</a:t>
+              <a:t>同じような会社も、</a:t>
             </a:r>
             <a:r>
               <a:rPr sz="2800" b="1" i="0">
@@ -22251,7 +22240,7 @@
                 <a:ea typeface="游ゴシック"/>
                 <a:cs typeface="游ゴシック"/>
               </a:rPr>
-              <a:t>もう越えています。</a:t>
+              <a:t>無理なく始めています。</a:t>
             </a:r>
           </a:p>
         </p:txBody>
@@ -22432,7 +22421,7 @@
                 <a:ea typeface="游ゴシック"/>
                 <a:cs typeface="游ゴシック"/>
               </a:rPr>
-              <a:t>むしろ50名いかない・事務3〜5名の会社が一番多く始めています。</a:t>
+              <a:t>数名〜数十名規模の会社から始める例も多くあります。</a:t>
             </a:r>
           </a:p>
         </p:txBody>
@@ -22613,7 +22602,7 @@
                 <a:ea typeface="游ゴシック"/>
                 <a:cs typeface="游ゴシック"/>
               </a:rPr>
-              <a:t>まだ“触り始め”の会社がほとんど。今なら十分に先頭集団です。</a:t>
+              <a:t>まだ“触り始め”の会社が多く、今からでも十分に間に合います。</a:t>
             </a:r>
           </a:p>
         </p:txBody>
@@ -22794,7 +22783,7 @@
                 <a:ea typeface="游ゴシック"/>
                 <a:cs typeface="游ゴシック"/>
               </a:rPr>
-              <a:t>建設・運送・医療・士業…同じ業界でも、皆さん最初はそう言われます。</a:t>
+              <a:t>同じ業界の会社でも、共通して使える場面は数多くあります。</a:t>
             </a:r>
           </a:p>
         </p:txBody>
@@ -22975,7 +22964,7 @@
                 <a:ea typeface="游ゴシック"/>
                 <a:cs typeface="游ゴシック"/>
               </a:rPr>
-              <a:t>20〜60代の全世代で好評。むしろ年配の方が“ラクになった”と。</a:t>
+              <a:t>幅広い年代の方に、ご好評をいただいています。</a:t>
             </a:r>
           </a:p>
         </p:txBody>

</xml_diff>

<commit_message>
Update SME track-record figures (community 20,000+, videos 800+)
- AI学習コミュニティ参加者数: 15,000名超 → 20,000名超
- 自社制作AI動画教材: 700本超 → 800本超

Co-Authored-By: Claude Opus 4.8 <noreply@anthropic.com>
Claude-Session: https://claude.ai/code/session_01NhMukK23UTNtqbV2vynVXs
</commit_message>
<xml_diff>
--- a/proposal/ai-training-proposal-sme.pptx
+++ b/proposal/ai-training-proposal-sme.pptx
@@ -21261,7 +21261,7 @@
                 <a:ea typeface="游ゴシック"/>
                 <a:cs typeface="游ゴシック"/>
               </a:rPr>
-              <a:t>15,000</a:t>
+              <a:t>20,000</a:t>
             </a:r>
             <a:r>
               <a:rPr sz="1250" b="1" i="0">
@@ -21385,7 +21385,7 @@
                 <a:ea typeface="游ゴシック"/>
                 <a:cs typeface="游ゴシック"/>
               </a:rPr>
-              <a:t>会員数</a:t>
+              <a:t>参加者数</a:t>
             </a:r>
           </a:p>
         </p:txBody>
@@ -21695,7 +21695,7 @@
                 <a:ea typeface="游ゴシック"/>
                 <a:cs typeface="游ゴシック"/>
               </a:rPr>
-              <a:t>700</a:t>
+              <a:t>800</a:t>
             </a:r>
             <a:r>
               <a:rPr sz="1250" b="1" i="0">

</xml_diff>